<commit_message>
Refresh demo script and submission deck
</commit_message>
<xml_diff>
--- a/submission/TON_Compass_Demo_Deck.pptx
+++ b/submission/TON_Compass_Demo_Deck.pptx
@@ -1372,7 +1372,7 @@
                 <a:ea typeface="Liberation Sans" pitchFamily="34" charset="-122"/>
                 <a:cs typeface="Liberation Sans" pitchFamily="34" charset="-120"/>
               </a:rPr>
-              <a:t>A guided first-move app for TON DeFi built on top of the official STON.fi execution layer.</a:t>
+              <a:t>A guided first-move app for TON DeFi built on top of the official STON.fi execution and data layer.</a:t>
             </a:r>
             <a:endParaRPr lang="en-US" sz="1200" dirty="0"/>
           </a:p>
@@ -1450,7 +1450,7 @@
                 <a:ea typeface="Liberation Sans" pitchFamily="34" charset="-122"/>
                 <a:cs typeface="Liberation Sans" pitchFamily="34" charset="-120"/>
               </a:rPr>
-              <a:t>Journey Builder, readiness preflight, live STON.fi swap execution, and a Tonstakers-ready next step.</a:t>
+              <a:t>Journey Builder, live quote checks, wallet-aware hints, official STON.fi execution, and a Tonstakers-ready continuation.</a:t>
             </a:r>
             <a:endParaRPr lang="en-US" sz="1150" dirty="0"/>
           </a:p>
@@ -1635,7 +1635,7 @@
                 <a:ea typeface="Liberation Sans" pitchFamily="34" charset="-122"/>
                 <a:cs typeface="Liberation Sans" pitchFamily="34" charset="-120"/>
               </a:rPr>
-              <a:t>Product</a:t>
+              <a:t>Decision</a:t>
             </a:r>
             <a:endParaRPr lang="en-US" sz="1200" dirty="0"/>
           </a:p>
@@ -1674,7 +1674,7 @@
                 <a:ea typeface="Liberation Sans" pitchFamily="34" charset="-122"/>
                 <a:cs typeface="Liberation Sans" pitchFamily="34" charset="-120"/>
               </a:rPr>
-              <a:t>Route guidance + readiness</a:t>
+              <a:t>Live quote + wallet hints</a:t>
             </a:r>
             <a:endParaRPr lang="en-US" sz="1050" dirty="0"/>
           </a:p>
@@ -1786,7 +1786,7 @@
                 <a:ea typeface="Liberation Sans" pitchFamily="34" charset="-122"/>
                 <a:cs typeface="Liberation Sans" pitchFamily="34" charset="-120"/>
               </a:rPr>
-              <a:t>Tonstakers continuation</a:t>
+              <a:t>Tonstakers + Telegram</a:t>
             </a:r>
             <a:endParaRPr lang="en-US" sz="1050" dirty="0"/>
           </a:p>
@@ -1842,8 +1842,8 @@
         </p:blipFill>
         <p:spPr>
           <a:xfrm>
-            <a:off x="6978982" y="868680"/>
-            <a:ext cx="2684116" cy="4846320"/>
+            <a:off x="6038256" y="868680"/>
+            <a:ext cx="4565568" cy="4846320"/>
           </a:xfrm>
           <a:prstGeom prst="rect">
             <a:avLst/>
@@ -1883,7 +1883,7 @@
                 <a:ea typeface="Liberation Sans" pitchFamily="34" charset="-122"/>
                 <a:cs typeface="Liberation Sans" pitchFamily="34" charset="-120"/>
               </a:rPr>
-              <a:t>TON Compass | Live demo already online</a:t>
+              <a:t>TON Compass | Guided route + live decision layer</a:t>
             </a:r>
             <a:endParaRPr lang="en-US" sz="1000" dirty="0"/>
           </a:p>
@@ -2735,7 +2735,7 @@
                 <a:ea typeface="Liberation Sans" pitchFamily="34" charset="-122"/>
                 <a:cs typeface="Liberation Sans" pitchFamily="34" charset="-120"/>
               </a:rPr>
-              <a:t>The product adds just enough structure around the official widget to feel like a real TON journey rather than a one-screen embed.</a:t>
+              <a:t>The product adds just enough structure around the official widget and public data layer to feel like a real TON journey rather than a one-screen embed.</a:t>
             </a:r>
             <a:endParaRPr lang="en-US" sz="1200" dirty="0"/>
           </a:p>
@@ -3082,7 +3082,7 @@
                 <a:ea typeface="Liberation Sans" pitchFamily="34" charset="-122"/>
                 <a:cs typeface="Liberation Sans" pitchFamily="34" charset="-120"/>
               </a:rPr>
-              <a:t>3. STON.fi execution</a:t>
+              <a:t>3. Decision Lab</a:t>
             </a:r>
             <a:endParaRPr lang="en-US" sz="1200" dirty="0"/>
           </a:p>
@@ -3121,7 +3121,7 @@
                 <a:ea typeface="Liberation Sans" pitchFamily="34" charset="-122"/>
                 <a:cs typeface="Liberation Sans" pitchFamily="34" charset="-120"/>
               </a:rPr>
-              <a:t>The real swap stays inside the official Omniston widget. No fake on-chain flow.</a:t>
+              <a:t>Pulls live STON.fi route simulation and wallet-aware hints from official public endpoints.</a:t>
             </a:r>
             <a:endParaRPr lang="en-US" sz="1050" dirty="0"/>
           </a:p>
@@ -3219,7 +3219,7 @@
                 <a:ea typeface="Liberation Sans" pitchFamily="34" charset="-122"/>
                 <a:cs typeface="Liberation Sans" pitchFamily="34" charset="-120"/>
               </a:rPr>
-              <a:t>4. Tonstakers continuation</a:t>
+              <a:t>4. Continuation</a:t>
             </a:r>
             <a:endParaRPr lang="en-US" sz="1200" dirty="0"/>
           </a:p>
@@ -3258,7 +3258,7 @@
                 <a:ea typeface="Liberation Sans" pitchFamily="34" charset="-122"/>
                 <a:cs typeface="Liberation Sans" pitchFamily="34" charset="-120"/>
               </a:rPr>
-              <a:t>After the first swap, the user gets a credible next action instead of a dead end.</a:t>
+              <a:t>The real swap stays in STON.fi, then Tonstakers and Telegram keep the journey alive.</a:t>
             </a:r>
             <a:endParaRPr lang="en-US" sz="1050" dirty="0"/>
           </a:p>
@@ -3324,7 +3324,7 @@
                 <a:ea typeface="Liberation Sans" pitchFamily="34" charset="-122"/>
                 <a:cs typeface="Liberation Sans" pitchFamily="34" charset="-120"/>
               </a:rPr>
-              <a:t>Result: a beginner can move from uncertainty -&gt; guided choice -&gt; real swap -&gt; TON-native continuation without ever leaving a coherent product surface.</a:t>
+              <a:t>Result: a beginner can move from uncertainty -&gt; guided choice -&gt; live quote -&gt; real swap -&gt; TON-native continuation without ever leaving a coherent product surface.</a:t>
             </a:r>
             <a:endParaRPr lang="en-US" sz="1600" dirty="0"/>
           </a:p>
@@ -3363,7 +3363,7 @@
                 <a:ea typeface="Liberation Sans" pitchFamily="34" charset="-122"/>
                 <a:cs typeface="Liberation Sans" pitchFamily="34" charset="-120"/>
               </a:rPr>
-              <a:t>Journey Builder -&gt; Readiness -&gt; STON.fi -&gt; Tonstakers</a:t>
+              <a:t>Journey Builder -&gt; Readiness -&gt; Decision Lab -&gt; Continuation</a:t>
             </a:r>
             <a:endParaRPr lang="en-US" sz="1000" dirty="0"/>
           </a:p>
@@ -3624,7 +3624,7 @@
                 <a:ea typeface="Liberation Sans" pitchFamily="34" charset="-122"/>
                 <a:cs typeface="Liberation Sans" pitchFamily="34" charset="-120"/>
               </a:rPr>
-              <a:t>Execution goes through the official STON.fi widget. The demo is not faking the core user action.</a:t>
+              <a:t>Execution goes through the official STON.fi widget and live protocol quotes come from official public STON.fi endpoints.</a:t>
             </a:r>
             <a:endParaRPr lang="en-US" sz="1050" dirty="0"/>
           </a:p>
@@ -3736,7 +3736,7 @@
                 <a:ea typeface="Liberation Sans" pitchFamily="34" charset="-122"/>
                 <a:cs typeface="Liberation Sans" pitchFamily="34" charset="-120"/>
               </a:rPr>
-              <a:t>Route recommendation, readiness gating, and shareable modes create a reusable onboarding system.</a:t>
+              <a:t>Route recommendation, readiness gating, live quote checks, and wallet-aware hints create a reusable onboarding system.</a:t>
             </a:r>
             <a:endParaRPr lang="en-US" sz="1050" dirty="0"/>
           </a:p>
@@ -3848,7 +3848,7 @@
                 <a:ea typeface="Liberation Sans" pitchFamily="34" charset="-122"/>
                 <a:cs typeface="Liberation Sans" pitchFamily="34" charset="-120"/>
               </a:rPr>
-              <a:t>Tonstakers shows how this can expand into a broader TON journey instead of stopping at swap.</a:t>
+              <a:t>Tonstakers plus Telegram continuity show how this can expand into a broader TON journey instead of stopping at swap.</a:t>
             </a:r>
             <a:endParaRPr lang="en-US" sz="1050" dirty="0"/>
           </a:p>
@@ -3963,7 +3963,7 @@
                 <a:ea typeface="Liberation Sans" pitchFamily="34" charset="-122"/>
                 <a:cs typeface="Liberation Sans" pitchFamily="34" charset="-120"/>
               </a:rPr>
-              <a:t>The app already supports a real user journey</a:t>
+              <a:t>The app already supports a real user journey plus a live decision layer</a:t>
             </a:r>
             <a:endParaRPr lang="en-US" sz="1500" dirty="0"/>
           </a:p>
@@ -4047,7 +4047,7 @@
                 <a:ea typeface="Liberation Sans" pitchFamily="34" charset="-122"/>
                 <a:cs typeface="Liberation Sans" pitchFamily="34" charset="-120"/>
               </a:rPr>
-              <a:t>TON Compass is not a swap clone. It is an onboarding product on top of STON.fi.</a:t>
+              <a:t>TON Compass is not a swap clone. It is an onboarding and decision product on top of STON.fi.</a:t>
             </a:r>
             <a:endParaRPr lang="en-US" sz="1600" dirty="0"/>
           </a:p>
@@ -4282,7 +4282,7 @@
         <p:spPr>
           <a:xfrm>
             <a:off x="731520" y="2148840"/>
-            <a:ext cx="5303520" cy="320040"/>
+            <a:ext cx="2743200" cy="274320"/>
           </a:xfrm>
           <a:prstGeom prst="rect">
             <a:avLst/>
@@ -4298,7 +4298,7 @@
               <a:buNone/>
             </a:pPr>
             <a:r>
-              <a:rPr lang="en-US" sz="1400" u="sng" dirty="0">
+              <a:rPr lang="en-US" sz="1500" b="1" u="sng" dirty="0">
                 <a:solidFill>
                   <a:srgbClr val="D8FF6B"/>
                 </a:solidFill>
@@ -4313,15 +4313,54 @@
                   </a:extLst>
                 </a:hlinkClick>
               </a:rPr>
-              <a:t>https://forlearningandcerts.sellsystems.agency:49184/ton-compass/index.html</a:t>
-            </a:r>
-            <a:endParaRPr lang="en-US" sz="1400" dirty="0"/>
+              <a:t>Open live web app</a:t>
+            </a:r>
+            <a:endParaRPr lang="en-US" sz="1500" dirty="0"/>
           </a:p>
         </p:txBody>
       </p:sp>
       <p:sp>
         <p:nvSpPr>
           <p:cNvPr id="7" name="Text 4"/>
+          <p:cNvSpPr/>
+          <p:nvPr/>
+        </p:nvSpPr>
+        <p:spPr>
+          <a:xfrm>
+            <a:off x="731520" y="2450592"/>
+            <a:ext cx="4754880" cy="256032"/>
+          </a:xfrm>
+          <a:prstGeom prst="rect">
+            <a:avLst/>
+          </a:prstGeom>
+          <a:noFill/>
+          <a:ln/>
+        </p:spPr>
+        <p:txBody>
+          <a:bodyPr wrap="square" lIns="0" tIns="0" rIns="0" bIns="0" rtlCol="0" anchor="ctr"/>
+          <a:lstStyle/>
+          <a:p>
+            <a:pPr indent="0" marL="0">
+              <a:buNone/>
+            </a:pPr>
+            <a:r>
+              <a:rPr lang="en-US" sz="1150" dirty="0">
+                <a:solidFill>
+                  <a:srgbClr val="B7C1D1"/>
+                </a:solidFill>
+                <a:latin typeface="Liberation Sans" pitchFamily="34" charset="0"/>
+                <a:ea typeface="Liberation Sans" pitchFamily="34" charset="-122"/>
+                <a:cs typeface="Liberation Sans" pitchFamily="34" charset="-120"/>
+              </a:rPr>
+              <a:t>forlearningandcerts.sellsystems.agency:49184/ton-compass</a:t>
+            </a:r>
+            <a:endParaRPr lang="en-US" sz="1150" dirty="0"/>
+          </a:p>
+        </p:txBody>
+      </p:sp>
+      <p:sp>
+        <p:nvSpPr>
+          <p:cNvPr id="8" name="Text 5"/>
           <p:cNvSpPr/>
           <p:nvPr/>
         </p:nvSpPr>
@@ -4360,7 +4399,7 @@
       </p:sp>
       <p:sp>
         <p:nvSpPr>
-          <p:cNvPr id="8" name="Text 5">
+          <p:cNvPr id="9" name="Text 6">
             <a:hlinkClick r:id="rId4" tooltip=""/>
           </p:cNvPr>
           <p:cNvSpPr/>
@@ -4369,7 +4408,7 @@
         <p:spPr>
           <a:xfrm>
             <a:off x="731520" y="3154680"/>
-            <a:ext cx="4206240" cy="320040"/>
+            <a:ext cx="2926080" cy="274320"/>
           </a:xfrm>
           <a:prstGeom prst="rect">
             <a:avLst/>
@@ -4385,7 +4424,7 @@
               <a:buNone/>
             </a:pPr>
             <a:r>
-              <a:rPr lang="en-US" sz="1400" u="sng" dirty="0">
+              <a:rPr lang="en-US" sz="1500" b="1" u="sng" dirty="0">
                 <a:solidFill>
                   <a:srgbClr val="D8FF6B"/>
                 </a:solidFill>
@@ -4400,15 +4439,54 @@
                   </a:extLst>
                 </a:hlinkClick>
               </a:rPr>
-              <a:t>https://github.com/ryuriymega/stonfi-hackathon</a:t>
-            </a:r>
-            <a:endParaRPr lang="en-US" sz="1400" dirty="0"/>
-          </a:p>
-        </p:txBody>
-      </p:sp>
-      <p:sp>
-        <p:nvSpPr>
-          <p:cNvPr id="9" name="Shape 6"/>
+              <a:t>Open GitHub repository</a:t>
+            </a:r>
+            <a:endParaRPr lang="en-US" sz="1500" dirty="0"/>
+          </a:p>
+        </p:txBody>
+      </p:sp>
+      <p:sp>
+        <p:nvSpPr>
+          <p:cNvPr id="10" name="Text 7"/>
+          <p:cNvSpPr/>
+          <p:nvPr/>
+        </p:nvSpPr>
+        <p:spPr>
+          <a:xfrm>
+            <a:off x="731520" y="3456432"/>
+            <a:ext cx="4023360" cy="256032"/>
+          </a:xfrm>
+          <a:prstGeom prst="rect">
+            <a:avLst/>
+          </a:prstGeom>
+          <a:noFill/>
+          <a:ln/>
+        </p:spPr>
+        <p:txBody>
+          <a:bodyPr wrap="square" lIns="0" tIns="0" rIns="0" bIns="0" rtlCol="0" anchor="ctr"/>
+          <a:lstStyle/>
+          <a:p>
+            <a:pPr indent="0" marL="0">
+              <a:buNone/>
+            </a:pPr>
+            <a:r>
+              <a:rPr lang="en-US" sz="1150" dirty="0">
+                <a:solidFill>
+                  <a:srgbClr val="B7C1D1"/>
+                </a:solidFill>
+                <a:latin typeface="Liberation Sans" pitchFamily="34" charset="0"/>
+                <a:ea typeface="Liberation Sans" pitchFamily="34" charset="-122"/>
+                <a:cs typeface="Liberation Sans" pitchFamily="34" charset="-120"/>
+              </a:rPr>
+              <a:t>github.com/ryuriymega/stonfi-hackathon</a:t>
+            </a:r>
+            <a:endParaRPr lang="en-US" sz="1150" dirty="0"/>
+          </a:p>
+        </p:txBody>
+      </p:sp>
+      <p:sp>
+        <p:nvSpPr>
+          <p:cNvPr id="11" name="Shape 8"/>
           <p:cNvSpPr/>
           <p:nvPr/>
         </p:nvSpPr>
@@ -4435,7 +4513,7 @@
       </p:sp>
       <p:sp>
         <p:nvSpPr>
-          <p:cNvPr id="10" name="Text 7"/>
+          <p:cNvPr id="12" name="Text 9"/>
           <p:cNvSpPr/>
           <p:nvPr/>
         </p:nvSpPr>
@@ -4474,7 +4552,7 @@
       </p:sp>
       <p:sp>
         <p:nvSpPr>
-          <p:cNvPr id="11" name="Text 8"/>
+          <p:cNvPr id="13" name="Text 10"/>
           <p:cNvSpPr/>
           <p:nvPr/>
         </p:nvSpPr>
@@ -4505,7 +4583,7 @@
                 <a:ea typeface="Liberation Sans" pitchFamily="34" charset="-122"/>
                 <a:cs typeface="Liberation Sans" pitchFamily="34" charset="-120"/>
               </a:rPr>
-              <a:t>TON Compass is a guided first-move app for TON DeFi. It recommends the right route, adds a readiness layer before wallet connection, executes through the official STON.fi widget, and then offers a Tonstakers-ready continuation path.</a:t>
+              <a:t>TON Compass is a guided first-move app for TON DeFi. It recommends the right route, adds a readiness layer before wallet connection, checks the route with live STON.fi data, executes through the official STON.fi widget, and then offers a Tonstakers-ready continuation path.</a:t>
             </a:r>
             <a:endParaRPr lang="en-US" sz="1500" dirty="0"/>
           </a:p>
@@ -4513,7 +4591,7 @@
       </p:sp>
       <p:sp>
         <p:nvSpPr>
-          <p:cNvPr id="12" name="Text 9"/>
+          <p:cNvPr id="14" name="Text 11"/>
           <p:cNvSpPr/>
           <p:nvPr/>
         </p:nvSpPr>
@@ -4544,7 +4622,7 @@
                 <a:ea typeface="Liberation Sans" pitchFamily="34" charset="-122"/>
                 <a:cs typeface="Liberation Sans" pitchFamily="34" charset="-120"/>
               </a:rPr>
-              <a:t>That makes it feel like the start of a TON journey, not just another swap clone.</a:t>
+              <a:t>That makes it feel like the start of a TON journey, not just another swap clone or widget wrapper.</a:t>
             </a:r>
             <a:endParaRPr lang="en-US" sz="1500" dirty="0"/>
           </a:p>

</xml_diff>